<commit_message>
Update: data.py supports Amazon All Beauty, sanity check generalized, hit ratio better
</commit_message>
<xml_diff>
--- a/M1.pptx
+++ b/M1.pptx
@@ -15265,13 +15265,13 @@
       <dgm:prSet presAssocID="{3092DB2D-E0B3-4F3A-B287-B493E83C5867}" presName="iconRect" presStyleLbl="node1" presStyleIdx="0" presStyleCnt="5"/>
       <dgm:spPr>
         <a:blipFill>
-          <a:blip xmlns:r="http://schemas.openxmlformats.org/officeDocument/2006/relationships" r:embed="rId1">
+          <a:blip xmlns:r="http://schemas.openxmlformats.org/officeDocument/2006/relationships">
             <a:extLst>
               <a:ext uri="{28A0092B-C50C-407E-A947-70E740481C1C}">
                 <a14:useLocalDpi xmlns:a14="http://schemas.microsoft.com/office/drawing/2010/main" val="0"/>
               </a:ext>
               <a:ext uri="{96DAC541-7B7A-43D3-8B79-37D633B846F1}">
-                <asvg:svgBlip xmlns:asvg="http://schemas.microsoft.com/office/drawing/2016/SVG/main" r:embed="rId2"/>
+                <asvg:svgBlip xmlns:asvg="http://schemas.microsoft.com/office/drawing/2016/SVG/main" r:embed="rId1"/>
               </a:ext>
             </a:extLst>
           </a:blip>
@@ -15318,10 +15318,10 @@
       <dgm:prSet presAssocID="{C65FD3BE-0E97-46AD-A7D9-97734FCF8171}" presName="iconRect" presStyleLbl="node1" presStyleIdx="1" presStyleCnt="5"/>
       <dgm:spPr>
         <a:blipFill>
-          <a:blip xmlns:r="http://schemas.openxmlformats.org/officeDocument/2006/relationships" r:embed="rId3">
+          <a:blip xmlns:r="http://schemas.openxmlformats.org/officeDocument/2006/relationships">
             <a:extLst>
               <a:ext uri="{96DAC541-7B7A-43D3-8B79-37D633B846F1}">
-                <asvg:svgBlip xmlns:asvg="http://schemas.microsoft.com/office/drawing/2016/SVG/main" r:embed="rId4"/>
+                <asvg:svgBlip xmlns:asvg="http://schemas.microsoft.com/office/drawing/2016/SVG/main" r:embed="rId2"/>
               </a:ext>
             </a:extLst>
           </a:blip>
@@ -15369,13 +15369,13 @@
       <dgm:prSet presAssocID="{40E131D3-5A56-46B6-92A8-ADBC3C0B42FC}" presName="iconRect" presStyleLbl="node1" presStyleIdx="2" presStyleCnt="5"/>
       <dgm:spPr>
         <a:blipFill>
-          <a:blip xmlns:r="http://schemas.openxmlformats.org/officeDocument/2006/relationships" r:embed="rId5">
+          <a:blip xmlns:r="http://schemas.openxmlformats.org/officeDocument/2006/relationships">
             <a:extLst>
               <a:ext uri="{28A0092B-C50C-407E-A947-70E740481C1C}">
                 <a14:useLocalDpi xmlns:a14="http://schemas.microsoft.com/office/drawing/2010/main" val="0"/>
               </a:ext>
               <a:ext uri="{96DAC541-7B7A-43D3-8B79-37D633B846F1}">
-                <asvg:svgBlip xmlns:asvg="http://schemas.microsoft.com/office/drawing/2016/SVG/main" r:embed="rId6"/>
+                <asvg:svgBlip xmlns:asvg="http://schemas.microsoft.com/office/drawing/2016/SVG/main" r:embed="rId3"/>
               </a:ext>
             </a:extLst>
           </a:blip>
@@ -15422,10 +15422,10 @@
       <dgm:prSet presAssocID="{99804475-8CF7-48A8-937F-1DE1720796E6}" presName="iconRect" presStyleLbl="node1" presStyleIdx="3" presStyleCnt="5"/>
       <dgm:spPr>
         <a:blipFill>
-          <a:blip xmlns:r="http://schemas.openxmlformats.org/officeDocument/2006/relationships" r:embed="rId7">
+          <a:blip xmlns:r="http://schemas.openxmlformats.org/officeDocument/2006/relationships">
             <a:extLst>
               <a:ext uri="{96DAC541-7B7A-43D3-8B79-37D633B846F1}">
-                <asvg:svgBlip xmlns:asvg="http://schemas.microsoft.com/office/drawing/2016/SVG/main" r:embed="rId8"/>
+                <asvg:svgBlip xmlns:asvg="http://schemas.microsoft.com/office/drawing/2016/SVG/main" r:embed="rId4"/>
               </a:ext>
             </a:extLst>
           </a:blip>
@@ -15480,13 +15480,13 @@
       <dgm:prSet presAssocID="{005BD9F2-BB52-461C-A3A3-BCBED0F79269}" presName="iconRect" presStyleLbl="node1" presStyleIdx="4" presStyleCnt="5"/>
       <dgm:spPr>
         <a:blipFill>
-          <a:blip xmlns:r="http://schemas.openxmlformats.org/officeDocument/2006/relationships" r:embed="rId9">
+          <a:blip xmlns:r="http://schemas.openxmlformats.org/officeDocument/2006/relationships">
             <a:extLst>
               <a:ext uri="{28A0092B-C50C-407E-A947-70E740481C1C}">
                 <a14:useLocalDpi xmlns:a14="http://schemas.microsoft.com/office/drawing/2010/main" val="0"/>
               </a:ext>
               <a:ext uri="{96DAC541-7B7A-43D3-8B79-37D633B846F1}">
-                <asvg:svgBlip xmlns:asvg="http://schemas.microsoft.com/office/drawing/2016/SVG/main" r:embed="rId10"/>
+                <asvg:svgBlip xmlns:asvg="http://schemas.microsoft.com/office/drawing/2016/SVG/main" r:embed="rId5"/>
               </a:ext>
             </a:extLst>
           </a:blip>
@@ -17599,13 +17599,13 @@
       <dgm:prSet presAssocID="{CEA436CB-3514-49F4-9200-FC885C472E0F}" presName="iconRect" presStyleLbl="node1" presStyleIdx="0" presStyleCnt="3"/>
       <dgm:spPr>
         <a:blipFill>
-          <a:blip xmlns:r="http://schemas.openxmlformats.org/officeDocument/2006/relationships" r:embed="rId1">
+          <a:blip xmlns:r="http://schemas.openxmlformats.org/officeDocument/2006/relationships">
             <a:extLst>
               <a:ext uri="{28A0092B-C50C-407E-A947-70E740481C1C}">
                 <a14:useLocalDpi xmlns:a14="http://schemas.microsoft.com/office/drawing/2010/main" val="0"/>
               </a:ext>
               <a:ext uri="{96DAC541-7B7A-43D3-8B79-37D633B846F1}">
-                <asvg:svgBlip xmlns:asvg="http://schemas.microsoft.com/office/drawing/2016/SVG/main" r:embed="rId2"/>
+                <asvg:svgBlip xmlns:asvg="http://schemas.microsoft.com/office/drawing/2016/SVG/main" r:embed="rId1"/>
               </a:ext>
             </a:extLst>
           </a:blip>
@@ -17652,13 +17652,13 @@
       <dgm:prSet presAssocID="{558E2BCE-3AAE-41D2-A424-BF1FA02B64C9}" presName="iconRect" presStyleLbl="node1" presStyleIdx="1" presStyleCnt="3"/>
       <dgm:spPr>
         <a:blipFill>
-          <a:blip xmlns:r="http://schemas.openxmlformats.org/officeDocument/2006/relationships" r:embed="rId3">
+          <a:blip xmlns:r="http://schemas.openxmlformats.org/officeDocument/2006/relationships">
             <a:extLst>
               <a:ext uri="{28A0092B-C50C-407E-A947-70E740481C1C}">
                 <a14:useLocalDpi xmlns:a14="http://schemas.microsoft.com/office/drawing/2010/main" val="0"/>
               </a:ext>
               <a:ext uri="{96DAC541-7B7A-43D3-8B79-37D633B846F1}">
-                <asvg:svgBlip xmlns:asvg="http://schemas.microsoft.com/office/drawing/2016/SVG/main" r:embed="rId4"/>
+                <asvg:svgBlip xmlns:asvg="http://schemas.microsoft.com/office/drawing/2016/SVG/main" r:embed="rId2"/>
               </a:ext>
             </a:extLst>
           </a:blip>
@@ -17705,13 +17705,13 @@
       <dgm:prSet presAssocID="{57DE8081-E63D-4FFB-879E-61F471697DFD}" presName="iconRect" presStyleLbl="node1" presStyleIdx="2" presStyleCnt="3"/>
       <dgm:spPr>
         <a:blipFill>
-          <a:blip xmlns:r="http://schemas.openxmlformats.org/officeDocument/2006/relationships" r:embed="rId5">
+          <a:blip xmlns:r="http://schemas.openxmlformats.org/officeDocument/2006/relationships">
             <a:extLst>
               <a:ext uri="{28A0092B-C50C-407E-A947-70E740481C1C}">
                 <a14:useLocalDpi xmlns:a14="http://schemas.microsoft.com/office/drawing/2010/main" val="0"/>
               </a:ext>
               <a:ext uri="{96DAC541-7B7A-43D3-8B79-37D633B846F1}">
-                <asvg:svgBlip xmlns:asvg="http://schemas.microsoft.com/office/drawing/2016/SVG/main" r:embed="rId6"/>
+                <asvg:svgBlip xmlns:asvg="http://schemas.microsoft.com/office/drawing/2016/SVG/main" r:embed="rId3"/>
               </a:ext>
             </a:extLst>
           </a:blip>
@@ -18694,13 +18694,13 @@
           <a:avLst/>
         </a:prstGeom>
         <a:blipFill>
-          <a:blip xmlns:r="http://schemas.openxmlformats.org/officeDocument/2006/relationships" r:embed="rId1">
+          <a:blip xmlns:r="http://schemas.openxmlformats.org/officeDocument/2006/relationships">
             <a:extLst>
               <a:ext uri="{28A0092B-C50C-407E-A947-70E740481C1C}">
                 <a14:useLocalDpi xmlns:a14="http://schemas.microsoft.com/office/drawing/2010/main" val="0"/>
               </a:ext>
               <a:ext uri="{96DAC541-7B7A-43D3-8B79-37D633B846F1}">
-                <asvg:svgBlip xmlns:asvg="http://schemas.microsoft.com/office/drawing/2016/SVG/main" r:embed="rId2"/>
+                <asvg:svgBlip xmlns:asvg="http://schemas.microsoft.com/office/drawing/2016/SVG/main" r:embed="rId1"/>
               </a:ext>
             </a:extLst>
           </a:blip>
@@ -18849,10 +18849,10 @@
           <a:avLst/>
         </a:prstGeom>
         <a:blipFill>
-          <a:blip xmlns:r="http://schemas.openxmlformats.org/officeDocument/2006/relationships" r:embed="rId3">
+          <a:blip xmlns:r="http://schemas.openxmlformats.org/officeDocument/2006/relationships">
             <a:extLst>
               <a:ext uri="{96DAC541-7B7A-43D3-8B79-37D633B846F1}">
-                <asvg:svgBlip xmlns:asvg="http://schemas.microsoft.com/office/drawing/2016/SVG/main" r:embed="rId4"/>
+                <asvg:svgBlip xmlns:asvg="http://schemas.microsoft.com/office/drawing/2016/SVG/main" r:embed="rId2"/>
               </a:ext>
             </a:extLst>
           </a:blip>
@@ -19002,13 +19002,13 @@
           <a:avLst/>
         </a:prstGeom>
         <a:blipFill>
-          <a:blip xmlns:r="http://schemas.openxmlformats.org/officeDocument/2006/relationships" r:embed="rId5">
+          <a:blip xmlns:r="http://schemas.openxmlformats.org/officeDocument/2006/relationships">
             <a:extLst>
               <a:ext uri="{28A0092B-C50C-407E-A947-70E740481C1C}">
                 <a14:useLocalDpi xmlns:a14="http://schemas.microsoft.com/office/drawing/2010/main" val="0"/>
               </a:ext>
               <a:ext uri="{96DAC541-7B7A-43D3-8B79-37D633B846F1}">
-                <asvg:svgBlip xmlns:asvg="http://schemas.microsoft.com/office/drawing/2016/SVG/main" r:embed="rId6"/>
+                <asvg:svgBlip xmlns:asvg="http://schemas.microsoft.com/office/drawing/2016/SVG/main" r:embed="rId3"/>
               </a:ext>
             </a:extLst>
           </a:blip>
@@ -19157,10 +19157,10 @@
           <a:avLst/>
         </a:prstGeom>
         <a:blipFill>
-          <a:blip xmlns:r="http://schemas.openxmlformats.org/officeDocument/2006/relationships" r:embed="rId7">
+          <a:blip xmlns:r="http://schemas.openxmlformats.org/officeDocument/2006/relationships">
             <a:extLst>
               <a:ext uri="{96DAC541-7B7A-43D3-8B79-37D633B846F1}">
-                <asvg:svgBlip xmlns:asvg="http://schemas.microsoft.com/office/drawing/2016/SVG/main" r:embed="rId8"/>
+                <asvg:svgBlip xmlns:asvg="http://schemas.microsoft.com/office/drawing/2016/SVG/main" r:embed="rId4"/>
               </a:ext>
             </a:extLst>
           </a:blip>
@@ -19308,13 +19308,13 @@
           <a:avLst/>
         </a:prstGeom>
         <a:blipFill>
-          <a:blip xmlns:r="http://schemas.openxmlformats.org/officeDocument/2006/relationships" r:embed="rId9">
+          <a:blip xmlns:r="http://schemas.openxmlformats.org/officeDocument/2006/relationships">
             <a:extLst>
               <a:ext uri="{28A0092B-C50C-407E-A947-70E740481C1C}">
                 <a14:useLocalDpi xmlns:a14="http://schemas.microsoft.com/office/drawing/2010/main" val="0"/>
               </a:ext>
               <a:ext uri="{96DAC541-7B7A-43D3-8B79-37D633B846F1}">
-                <asvg:svgBlip xmlns:asvg="http://schemas.microsoft.com/office/drawing/2016/SVG/main" r:embed="rId10"/>
+                <asvg:svgBlip xmlns:asvg="http://schemas.microsoft.com/office/drawing/2016/SVG/main" r:embed="rId5"/>
               </a:ext>
             </a:extLst>
           </a:blip>
@@ -21511,13 +21511,13 @@
           <a:avLst/>
         </a:prstGeom>
         <a:blipFill>
-          <a:blip xmlns:r="http://schemas.openxmlformats.org/officeDocument/2006/relationships" r:embed="rId1">
+          <a:blip xmlns:r="http://schemas.openxmlformats.org/officeDocument/2006/relationships">
             <a:extLst>
               <a:ext uri="{28A0092B-C50C-407E-A947-70E740481C1C}">
                 <a14:useLocalDpi xmlns:a14="http://schemas.microsoft.com/office/drawing/2010/main" val="0"/>
               </a:ext>
               <a:ext uri="{96DAC541-7B7A-43D3-8B79-37D633B846F1}">
-                <asvg:svgBlip xmlns:asvg="http://schemas.microsoft.com/office/drawing/2016/SVG/main" r:embed="rId2"/>
+                <asvg:svgBlip xmlns:asvg="http://schemas.microsoft.com/office/drawing/2016/SVG/main" r:embed="rId1"/>
               </a:ext>
             </a:extLst>
           </a:blip>
@@ -21662,13 +21662,13 @@
           <a:avLst/>
         </a:prstGeom>
         <a:blipFill>
-          <a:blip xmlns:r="http://schemas.openxmlformats.org/officeDocument/2006/relationships" r:embed="rId3">
+          <a:blip xmlns:r="http://schemas.openxmlformats.org/officeDocument/2006/relationships">
             <a:extLst>
               <a:ext uri="{28A0092B-C50C-407E-A947-70E740481C1C}">
                 <a14:useLocalDpi xmlns:a14="http://schemas.microsoft.com/office/drawing/2010/main" val="0"/>
               </a:ext>
               <a:ext uri="{96DAC541-7B7A-43D3-8B79-37D633B846F1}">
-                <asvg:svgBlip xmlns:asvg="http://schemas.microsoft.com/office/drawing/2016/SVG/main" r:embed="rId4"/>
+                <asvg:svgBlip xmlns:asvg="http://schemas.microsoft.com/office/drawing/2016/SVG/main" r:embed="rId2"/>
               </a:ext>
             </a:extLst>
           </a:blip>
@@ -21813,13 +21813,13 @@
           <a:avLst/>
         </a:prstGeom>
         <a:blipFill>
-          <a:blip xmlns:r="http://schemas.openxmlformats.org/officeDocument/2006/relationships" r:embed="rId5">
+          <a:blip xmlns:r="http://schemas.openxmlformats.org/officeDocument/2006/relationships">
             <a:extLst>
               <a:ext uri="{28A0092B-C50C-407E-A947-70E740481C1C}">
                 <a14:useLocalDpi xmlns:a14="http://schemas.microsoft.com/office/drawing/2010/main" val="0"/>
               </a:ext>
               <a:ext uri="{96DAC541-7B7A-43D3-8B79-37D633B846F1}">
-                <asvg:svgBlip xmlns:asvg="http://schemas.microsoft.com/office/drawing/2016/SVG/main" r:embed="rId6"/>
+                <asvg:svgBlip xmlns:asvg="http://schemas.microsoft.com/office/drawing/2016/SVG/main" r:embed="rId3"/>
               </a:ext>
             </a:extLst>
           </a:blip>
@@ -33124,7 +33124,7 @@
           <a:p>
             <a:fld id="{2D7B20B0-53B3-4EE3-8A10-192FFABE28CE}" type="datetimeFigureOut">
               <a:rPr lang="it-IT" smtClean="0"/>
-              <a:t>12/02/2026</a:t>
+              <a:t>10/04/2026</a:t>
             </a:fld>
             <a:endParaRPr lang="it-IT"/>
           </a:p>
@@ -33560,7 +33560,7 @@
           <a:p>
             <a:fld id="{2D7B20B0-53B3-4EE3-8A10-192FFABE28CE}" type="datetimeFigureOut">
               <a:rPr lang="it-IT" smtClean="0"/>
-              <a:t>12/02/2026</a:t>
+              <a:t>10/04/2026</a:t>
             </a:fld>
             <a:endParaRPr lang="it-IT"/>
           </a:p>
@@ -33810,7 +33810,7 @@
           <a:p>
             <a:fld id="{2D7B20B0-53B3-4EE3-8A10-192FFABE28CE}" type="datetimeFigureOut">
               <a:rPr lang="it-IT" smtClean="0"/>
-              <a:t>12/02/2026</a:t>
+              <a:t>10/04/2026</a:t>
             </a:fld>
             <a:endParaRPr lang="it-IT"/>
           </a:p>
@@ -34118,7 +34118,7 @@
           <a:p>
             <a:fld id="{2D7B20B0-53B3-4EE3-8A10-192FFABE28CE}" type="datetimeFigureOut">
               <a:rPr lang="it-IT" smtClean="0"/>
-              <a:t>12/02/2026</a:t>
+              <a:t>10/04/2026</a:t>
             </a:fld>
             <a:endParaRPr lang="it-IT"/>
           </a:p>
@@ -34436,7 +34436,7 @@
           <a:p>
             <a:fld id="{2D7B20B0-53B3-4EE3-8A10-192FFABE28CE}" type="datetimeFigureOut">
               <a:rPr lang="it-IT" smtClean="0"/>
-              <a:t>12/02/2026</a:t>
+              <a:t>10/04/2026</a:t>
             </a:fld>
             <a:endParaRPr lang="it-IT"/>
           </a:p>
@@ -34738,7 +34738,7 @@
           <a:p>
             <a:fld id="{2D7B20B0-53B3-4EE3-8A10-192FFABE28CE}" type="datetimeFigureOut">
               <a:rPr lang="it-IT" smtClean="0"/>
-              <a:t>12/02/2026</a:t>
+              <a:t>10/04/2026</a:t>
             </a:fld>
             <a:endParaRPr lang="it-IT"/>
           </a:p>
@@ -35105,7 +35105,7 @@
           <a:p>
             <a:fld id="{2D7B20B0-53B3-4EE3-8A10-192FFABE28CE}" type="datetimeFigureOut">
               <a:rPr lang="it-IT" smtClean="0"/>
-              <a:t>12/02/2026</a:t>
+              <a:t>10/04/2026</a:t>
             </a:fld>
             <a:endParaRPr lang="it-IT"/>
           </a:p>
@@ -35279,7 +35279,7 @@
           <a:p>
             <a:fld id="{2D7B20B0-53B3-4EE3-8A10-192FFABE28CE}" type="datetimeFigureOut">
               <a:rPr lang="it-IT" smtClean="0"/>
-              <a:t>12/02/2026</a:t>
+              <a:t>10/04/2026</a:t>
             </a:fld>
             <a:endParaRPr lang="it-IT"/>
           </a:p>
@@ -35459,7 +35459,7 @@
           <a:p>
             <a:fld id="{2D7B20B0-53B3-4EE3-8A10-192FFABE28CE}" type="datetimeFigureOut">
               <a:rPr lang="it-IT" smtClean="0"/>
-              <a:t>12/02/2026</a:t>
+              <a:t>10/04/2026</a:t>
             </a:fld>
             <a:endParaRPr lang="it-IT"/>
           </a:p>
@@ -35629,7 +35629,7 @@
           <a:p>
             <a:fld id="{2D7B20B0-53B3-4EE3-8A10-192FFABE28CE}" type="datetimeFigureOut">
               <a:rPr lang="it-IT" smtClean="0"/>
-              <a:t>12/02/2026</a:t>
+              <a:t>10/04/2026</a:t>
             </a:fld>
             <a:endParaRPr lang="it-IT"/>
           </a:p>
@@ -35879,7 +35879,7 @@
           <a:p>
             <a:fld id="{2D7B20B0-53B3-4EE3-8A10-192FFABE28CE}" type="datetimeFigureOut">
               <a:rPr lang="it-IT" smtClean="0"/>
-              <a:t>12/02/2026</a:t>
+              <a:t>10/04/2026</a:t>
             </a:fld>
             <a:endParaRPr lang="it-IT"/>
           </a:p>
@@ -36115,7 +36115,7 @@
           <a:p>
             <a:fld id="{2D7B20B0-53B3-4EE3-8A10-192FFABE28CE}" type="datetimeFigureOut">
               <a:rPr lang="it-IT" smtClean="0"/>
-              <a:t>12/02/2026</a:t>
+              <a:t>10/04/2026</a:t>
             </a:fld>
             <a:endParaRPr lang="it-IT"/>
           </a:p>
@@ -36497,7 +36497,7 @@
           <a:p>
             <a:fld id="{2D7B20B0-53B3-4EE3-8A10-192FFABE28CE}" type="datetimeFigureOut">
               <a:rPr lang="it-IT" smtClean="0"/>
-              <a:t>12/02/2026</a:t>
+              <a:t>10/04/2026</a:t>
             </a:fld>
             <a:endParaRPr lang="it-IT"/>
           </a:p>
@@ -36615,7 +36615,7 @@
           <a:p>
             <a:fld id="{2D7B20B0-53B3-4EE3-8A10-192FFABE28CE}" type="datetimeFigureOut">
               <a:rPr lang="it-IT" smtClean="0"/>
-              <a:t>12/02/2026</a:t>
+              <a:t>10/04/2026</a:t>
             </a:fld>
             <a:endParaRPr lang="it-IT"/>
           </a:p>
@@ -36710,7 +36710,7 @@
           <a:p>
             <a:fld id="{2D7B20B0-53B3-4EE3-8A10-192FFABE28CE}" type="datetimeFigureOut">
               <a:rPr lang="it-IT" smtClean="0"/>
-              <a:t>12/02/2026</a:t>
+              <a:t>10/04/2026</a:t>
             </a:fld>
             <a:endParaRPr lang="it-IT"/>
           </a:p>
@@ -36965,7 +36965,7 @@
           <a:p>
             <a:fld id="{2D7B20B0-53B3-4EE3-8A10-192FFABE28CE}" type="datetimeFigureOut">
               <a:rPr lang="it-IT" smtClean="0"/>
-              <a:t>12/02/2026</a:t>
+              <a:t>10/04/2026</a:t>
             </a:fld>
             <a:endParaRPr lang="it-IT"/>
           </a:p>
@@ -37248,7 +37248,7 @@
           <a:p>
             <a:fld id="{2D7B20B0-53B3-4EE3-8A10-192FFABE28CE}" type="datetimeFigureOut">
               <a:rPr lang="it-IT" smtClean="0"/>
-              <a:t>12/02/2026</a:t>
+              <a:t>10/04/2026</a:t>
             </a:fld>
             <a:endParaRPr lang="it-IT"/>
           </a:p>
@@ -37654,7 +37654,7 @@
           <a:p>
             <a:fld id="{2D7B20B0-53B3-4EE3-8A10-192FFABE28CE}" type="datetimeFigureOut">
               <a:rPr lang="it-IT" smtClean="0"/>
-              <a:t>12/02/2026</a:t>
+              <a:t>10/04/2026</a:t>
             </a:fld>
             <a:endParaRPr lang="it-IT"/>
           </a:p>
@@ -38304,7 +38304,7 @@
           <a:p>
             <a:r>
               <a:rPr lang="en-US" noProof="1"/>
-              <a:t>Inference and training time (ml-1m-csv dataset)</a:t>
+              <a:t>training time AND HIT RATIO (ml-1m-csv dataset)</a:t>
             </a:r>
           </a:p>
         </p:txBody>
@@ -39307,10 +39307,10 @@
           <p:nvPr/>
         </p:nvPicPr>
         <p:blipFill>
-          <a:blip r:embed="rId2">
+          <a:blip>
             <a:extLst>
               <a:ext uri="{96DAC541-7B7A-43D3-8B79-37D633B846F1}">
-                <asvg:svgBlip xmlns:asvg="http://schemas.microsoft.com/office/drawing/2016/SVG/main" r:embed="rId3"/>
+                <asvg:svgBlip xmlns:asvg="http://schemas.microsoft.com/office/drawing/2016/SVG/main" r:embed="rId2"/>
               </a:ext>
             </a:extLst>
           </a:blip>
@@ -39438,10 +39438,10 @@
           <p:nvPr/>
         </p:nvPicPr>
         <p:blipFill>
-          <a:blip r:embed="rId2">
+          <a:blip>
             <a:extLst>
               <a:ext uri="{96DAC541-7B7A-43D3-8B79-37D633B846F1}">
-                <asvg:svgBlip xmlns:asvg="http://schemas.microsoft.com/office/drawing/2016/SVG/main" r:embed="rId3"/>
+                <asvg:svgBlip xmlns:asvg="http://schemas.microsoft.com/office/drawing/2016/SVG/main" r:embed="rId2"/>
               </a:ext>
             </a:extLst>
           </a:blip>
@@ -39474,10 +39474,10 @@
           <p:nvPr/>
         </p:nvPicPr>
         <p:blipFill>
-          <a:blip r:embed="rId2">
+          <a:blip>
             <a:extLst>
               <a:ext uri="{96DAC541-7B7A-43D3-8B79-37D633B846F1}">
-                <asvg:svgBlip xmlns:asvg="http://schemas.microsoft.com/office/drawing/2016/SVG/main" r:embed="rId3"/>
+                <asvg:svgBlip xmlns:asvg="http://schemas.microsoft.com/office/drawing/2016/SVG/main" r:embed="rId2"/>
               </a:ext>
             </a:extLst>
           </a:blip>
@@ -41727,7 +41727,7 @@
                 </a:solidFill>
                 <a:latin typeface="Google Sans Text"/>
               </a:rPr>
-              <a:t> At 7,500 RPS, </a:t>
+              <a:t> At 10000 RPS, </a:t>
             </a:r>
             <a:r>
               <a:rPr lang="en-US" altLang="en-US" sz="1700" b="1" dirty="0">
@@ -43031,13 +43031,13 @@
               <a:avLst/>
             </a:prstGeom>
             <a:blipFill>
-              <a:blip r:embed="rId2">
+              <a:blip>
                 <a:extLst>
                   <a:ext uri="{28A0092B-C50C-407E-A947-70E740481C1C}">
                     <a14:useLocalDpi xmlns:a14="http://schemas.microsoft.com/office/drawing/2010/main" val="0"/>
                   </a:ext>
                   <a:ext uri="{96DAC541-7B7A-43D3-8B79-37D633B846F1}">
-                    <asvg:svgBlip xmlns:asvg="http://schemas.microsoft.com/office/drawing/2016/SVG/main" r:embed="rId3"/>
+                    <asvg:svgBlip xmlns:asvg="http://schemas.microsoft.com/office/drawing/2016/SVG/main" r:embed="rId2"/>
                   </a:ext>
                 </a:extLst>
               </a:blip>
@@ -43239,13 +43239,13 @@
               <a:avLst/>
             </a:prstGeom>
             <a:blipFill>
-              <a:blip r:embed="rId4">
+              <a:blip>
                 <a:extLst>
                   <a:ext uri="{28A0092B-C50C-407E-A947-70E740481C1C}">
                     <a14:useLocalDpi xmlns:a14="http://schemas.microsoft.com/office/drawing/2010/main" val="0"/>
                   </a:ext>
                   <a:ext uri="{96DAC541-7B7A-43D3-8B79-37D633B846F1}">
-                    <asvg:svgBlip xmlns:asvg="http://schemas.microsoft.com/office/drawing/2016/SVG/main" r:embed="rId5"/>
+                    <asvg:svgBlip xmlns:asvg="http://schemas.microsoft.com/office/drawing/2016/SVG/main" r:embed="rId3"/>
                   </a:ext>
                 </a:extLst>
               </a:blip>
@@ -43443,13 +43443,13 @@
               <a:avLst/>
             </a:prstGeom>
             <a:blipFill>
-              <a:blip r:embed="rId6">
+              <a:blip>
                 <a:extLst>
                   <a:ext uri="{28A0092B-C50C-407E-A947-70E740481C1C}">
                     <a14:useLocalDpi xmlns:a14="http://schemas.microsoft.com/office/drawing/2010/main" val="0"/>
                   </a:ext>
                   <a:ext uri="{96DAC541-7B7A-43D3-8B79-37D633B846F1}">
-                    <asvg:svgBlip xmlns:asvg="http://schemas.microsoft.com/office/drawing/2016/SVG/main" r:embed="rId7"/>
+                    <asvg:svgBlip xmlns:asvg="http://schemas.microsoft.com/office/drawing/2016/SVG/main" r:embed="rId4"/>
                   </a:ext>
                 </a:extLst>
               </a:blip>
@@ -43647,13 +43647,13 @@
               <a:avLst/>
             </a:prstGeom>
             <a:blipFill>
-              <a:blip r:embed="rId8">
+              <a:blip>
                 <a:extLst>
                   <a:ext uri="{28A0092B-C50C-407E-A947-70E740481C1C}">
                     <a14:useLocalDpi xmlns:a14="http://schemas.microsoft.com/office/drawing/2010/main" val="0"/>
                   </a:ext>
                   <a:ext uri="{96DAC541-7B7A-43D3-8B79-37D633B846F1}">
-                    <asvg:svgBlip xmlns:asvg="http://schemas.microsoft.com/office/drawing/2016/SVG/main" r:embed="rId9"/>
+                    <asvg:svgBlip xmlns:asvg="http://schemas.microsoft.com/office/drawing/2016/SVG/main" r:embed="rId5"/>
                   </a:ext>
                 </a:extLst>
               </a:blip>
@@ -45503,7 +45503,7 @@
           <a:p>
             <a:r>
               <a:rPr lang="en-US" noProof="1"/>
-              <a:t>Inference TIME AND HIT RATIO (ml-latest-small dataset)</a:t>
+              <a:t>TRAINING TIME AND HIT RATIO (ml-latest-small dataset)</a:t>
             </a:r>
           </a:p>
         </p:txBody>

</xml_diff>